<commit_message>
Harden five-day curriculum and portable AI program
</commit_message>
<xml_diff>
--- a/marketing/decks/phase-05-5-skills-registry.pptx
+++ b/marketing/decks/phase-05-5-skills-registry.pptx
@@ -2,24 +2,24 @@
 <file path=ppt/presentation.xml><?xml version="1.0" encoding="utf-8"?>
 <p:presentation xmlns:p="http://schemas.openxmlformats.org/presentationml/2006/main">
   <p:sldMasterIdLst>
-    <p:sldMasterId xmlns:r="http://schemas.openxmlformats.org/officeDocument/2006/relationships" id="2147483648" r:id="Rc252a01b198a4bd8"/>
+    <p:sldMasterId xmlns:r="http://schemas.openxmlformats.org/officeDocument/2006/relationships" id="2147483648" r:id="Rb84bf8bbe6424dd0"/>
   </p:sldMasterIdLst>
   <p:notesMasterIdLst>
-    <p:notesMasterId xmlns:r="http://schemas.openxmlformats.org/officeDocument/2006/relationships" r:id="Rc24815a2bf8045b3"/>
+    <p:notesMasterId xmlns:r="http://schemas.openxmlformats.org/officeDocument/2006/relationships" r:id="Rb34436a15fa8430e"/>
   </p:notesMasterIdLst>
   <p:sldIdLst>
-    <p:sldId xmlns:r="http://schemas.openxmlformats.org/officeDocument/2006/relationships" id="256" r:id="R8deda108e9ff455c"/>
-    <p:sldId xmlns:r="http://schemas.openxmlformats.org/officeDocument/2006/relationships" id="257" r:id="R004257185a2e4b37"/>
-    <p:sldId xmlns:r="http://schemas.openxmlformats.org/officeDocument/2006/relationships" id="258" r:id="R15148eec78b84b99"/>
-    <p:sldId xmlns:r="http://schemas.openxmlformats.org/officeDocument/2006/relationships" id="259" r:id="R049cd73f08f5465b"/>
-    <p:sldId xmlns:r="http://schemas.openxmlformats.org/officeDocument/2006/relationships" id="260" r:id="Ref92b437bf954e15"/>
-    <p:sldId xmlns:r="http://schemas.openxmlformats.org/officeDocument/2006/relationships" id="261" r:id="R4dcf6638c5364a23"/>
-    <p:sldId xmlns:r="http://schemas.openxmlformats.org/officeDocument/2006/relationships" id="262" r:id="R0591bfd10ad94a6a"/>
-    <p:sldId xmlns:r="http://schemas.openxmlformats.org/officeDocument/2006/relationships" id="263" r:id="Rea7ae978e27c46bd"/>
-    <p:sldId xmlns:r="http://schemas.openxmlformats.org/officeDocument/2006/relationships" id="264" r:id="Rafd497333e834464"/>
-    <p:sldId xmlns:r="http://schemas.openxmlformats.org/officeDocument/2006/relationships" id="265" r:id="R3831aa411cb44463"/>
-    <p:sldId xmlns:r="http://schemas.openxmlformats.org/officeDocument/2006/relationships" id="266" r:id="R67d3ed70fe784174"/>
-    <p:sldId xmlns:r="http://schemas.openxmlformats.org/officeDocument/2006/relationships" id="267" r:id="R6430056a9a134d0c"/>
+    <p:sldId xmlns:r="http://schemas.openxmlformats.org/officeDocument/2006/relationships" id="256" r:id="R9f6f4f4a542e4fb2"/>
+    <p:sldId xmlns:r="http://schemas.openxmlformats.org/officeDocument/2006/relationships" id="257" r:id="Rc760d542b8364f4b"/>
+    <p:sldId xmlns:r="http://schemas.openxmlformats.org/officeDocument/2006/relationships" id="258" r:id="R056e22e5196a46dc"/>
+    <p:sldId xmlns:r="http://schemas.openxmlformats.org/officeDocument/2006/relationships" id="259" r:id="R6709ed49509546a8"/>
+    <p:sldId xmlns:r="http://schemas.openxmlformats.org/officeDocument/2006/relationships" id="260" r:id="R30a019e8c6674b7c"/>
+    <p:sldId xmlns:r="http://schemas.openxmlformats.org/officeDocument/2006/relationships" id="261" r:id="R15981a19f2184389"/>
+    <p:sldId xmlns:r="http://schemas.openxmlformats.org/officeDocument/2006/relationships" id="262" r:id="R0e1f4aa6c99d4831"/>
+    <p:sldId xmlns:r="http://schemas.openxmlformats.org/officeDocument/2006/relationships" id="263" r:id="Re0ef964195b14366"/>
+    <p:sldId xmlns:r="http://schemas.openxmlformats.org/officeDocument/2006/relationships" id="264" r:id="R9b8dcac30bd34efb"/>
+    <p:sldId xmlns:r="http://schemas.openxmlformats.org/officeDocument/2006/relationships" id="265" r:id="Rcd03f486ffad4259"/>
+    <p:sldId xmlns:r="http://schemas.openxmlformats.org/officeDocument/2006/relationships" id="266" r:id="R146ad9d1808b4e77"/>
+    <p:sldId xmlns:r="http://schemas.openxmlformats.org/officeDocument/2006/relationships" id="267" r:id="Raae4474acae740f4"/>
   </p:sldIdLst>
   <p:sldSz cx="12192000" cy="6858000"/>
   <p:notesSz cx="6858000" cy="9144000"/>
@@ -476,7 +476,7 @@
           <a:lstStyle xmlns:a="http://schemas.openxmlformats.org/drawingml/2006/main"/>
           <a:p xmlns:a="http://schemas.openxmlformats.org/drawingml/2006/main">
             <a:r>
-              <a:t>Teach from docs/phases/05.5 and the skills-program handbook.\n\n[Sources]\n- marketing/lesson-plans/phase-05.5.md\n[/Sources]</a:t>
+              <a:t>Teach from docs/phases/05.5 and docs/ai-program.\n\n[Sources]\n- marketing/lesson-plans/phase-05.5.md\n[/Sources]</a:t>
             </a:r>
           </a:p>
         </p:txBody>
@@ -546,7 +546,7 @@
           <a:lstStyle xmlns:a="http://schemas.openxmlformats.org/drawingml/2006/main"/>
           <a:p xmlns:a="http://schemas.openxmlformats.org/drawingml/2006/main">
             <a:r>
-              <a:t>Teach from docs/phases/05.5 and the skills-program handbook.\n\n[Sources]\n- marketing/lesson-plans/phase-05.5.md\n[/Sources]</a:t>
+              <a:t>Teach from docs/phases/05.5 and docs/ai-program.\n\n[Sources]\n- marketing/lesson-plans/phase-05.5.md\n[/Sources]</a:t>
             </a:r>
           </a:p>
         </p:txBody>
@@ -616,7 +616,7 @@
           <a:lstStyle xmlns:a="http://schemas.openxmlformats.org/drawingml/2006/main"/>
           <a:p xmlns:a="http://schemas.openxmlformats.org/drawingml/2006/main">
             <a:r>
-              <a:t>Teach from docs/phases/05.5 and the skills-program handbook.\n\n[Sources]\n- marketing/lesson-plans/phase-05.5.md\n[/Sources]</a:t>
+              <a:t>Teach from docs/phases/05.5 and docs/ai-program.\n\n[Sources]\n- marketing/lesson-plans/phase-05.5.md\n[/Sources]</a:t>
             </a:r>
           </a:p>
         </p:txBody>
@@ -686,7 +686,7 @@
           <a:lstStyle xmlns:a="http://schemas.openxmlformats.org/drawingml/2006/main"/>
           <a:p xmlns:a="http://schemas.openxmlformats.org/drawingml/2006/main">
             <a:r>
-              <a:t>Teach from docs/phases/05.5 and the skills-program handbook.\n\n[Sources]\n- marketing/lesson-plans/phase-05.5.md\n[/Sources]</a:t>
+              <a:t>Teach from docs/phases/05.5 and docs/ai-program.\n\n[Sources]\n- marketing/lesson-plans/phase-05.5.md\n[/Sources]</a:t>
             </a:r>
           </a:p>
         </p:txBody>
@@ -756,7 +756,7 @@
           <a:lstStyle xmlns:a="http://schemas.openxmlformats.org/drawingml/2006/main"/>
           <a:p xmlns:a="http://schemas.openxmlformats.org/drawingml/2006/main">
             <a:r>
-              <a:t>Teach from docs/phases/05.5 and the skills-program handbook.\n\n[Sources]\n- marketing/lesson-plans/phase-05.5.md\n[/Sources]</a:t>
+              <a:t>Teach from docs/phases/05.5 and docs/ai-program.\n\n[Sources]\n- marketing/lesson-plans/phase-05.5.md\n[/Sources]</a:t>
             </a:r>
           </a:p>
         </p:txBody>
@@ -826,7 +826,7 @@
           <a:lstStyle xmlns:a="http://schemas.openxmlformats.org/drawingml/2006/main"/>
           <a:p xmlns:a="http://schemas.openxmlformats.org/drawingml/2006/main">
             <a:r>
-              <a:t>Teach from docs/phases/05.5 and the skills-program handbook.\n\n[Sources]\n- marketing/lesson-plans/phase-05.5.md\n[/Sources]</a:t>
+              <a:t>Teach from docs/phases/05.5 and docs/ai-program.\n\n[Sources]\n- marketing/lesson-plans/phase-05.5.md\n[/Sources]</a:t>
             </a:r>
           </a:p>
         </p:txBody>
@@ -896,7 +896,7 @@
           <a:lstStyle xmlns:a="http://schemas.openxmlformats.org/drawingml/2006/main"/>
           <a:p xmlns:a="http://schemas.openxmlformats.org/drawingml/2006/main">
             <a:r>
-              <a:t>Teach from docs/phases/05.5 and the skills-program handbook.\n\n[Sources]\n- marketing/lesson-plans/phase-05.5.md\n[/Sources]</a:t>
+              <a:t>Teach from docs/phases/05.5 and docs/ai-program.\n\n[Sources]\n- marketing/lesson-plans/phase-05.5.md\n[/Sources]</a:t>
             </a:r>
           </a:p>
         </p:txBody>
@@ -966,7 +966,7 @@
           <a:lstStyle xmlns:a="http://schemas.openxmlformats.org/drawingml/2006/main"/>
           <a:p xmlns:a="http://schemas.openxmlformats.org/drawingml/2006/main">
             <a:r>
-              <a:t>Teach from docs/phases/05.5 and the skills-program handbook.\n\n[Sources]\n- marketing/lesson-plans/phase-05.5.md\n[/Sources]</a:t>
+              <a:t>Teach from docs/phases/05.5 and docs/ai-program.\n\n[Sources]\n- marketing/lesson-plans/phase-05.5.md\n[/Sources]</a:t>
             </a:r>
           </a:p>
         </p:txBody>
@@ -1036,7 +1036,7 @@
           <a:lstStyle xmlns:a="http://schemas.openxmlformats.org/drawingml/2006/main"/>
           <a:p xmlns:a="http://schemas.openxmlformats.org/drawingml/2006/main">
             <a:r>
-              <a:t>Teach from docs/phases/05.5 and the skills-program handbook.\n\n[Sources]\n- marketing/lesson-plans/phase-05.5.md\n[/Sources]</a:t>
+              <a:t>Teach from docs/phases/05.5 and docs/ai-program.\n\n[Sources]\n- marketing/lesson-plans/phase-05.5.md\n[/Sources]</a:t>
             </a:r>
           </a:p>
         </p:txBody>
@@ -1106,7 +1106,7 @@
           <a:lstStyle xmlns:a="http://schemas.openxmlformats.org/drawingml/2006/main"/>
           <a:p xmlns:a="http://schemas.openxmlformats.org/drawingml/2006/main">
             <a:r>
-              <a:t>Teach from docs/phases/05.5 and the skills-program handbook.\n\n[Sources]\n- marketing/lesson-plans/phase-05.5.md\n[/Sources]</a:t>
+              <a:t>Teach from docs/phases/05.5 and docs/ai-program.\n\n[Sources]\n- marketing/lesson-plans/phase-05.5.md\n[/Sources]</a:t>
             </a:r>
           </a:p>
         </p:txBody>
@@ -1176,7 +1176,7 @@
           <a:lstStyle xmlns:a="http://schemas.openxmlformats.org/drawingml/2006/main"/>
           <a:p xmlns:a="http://schemas.openxmlformats.org/drawingml/2006/main">
             <a:r>
-              <a:t>Teach from docs/phases/05.5 and the skills-program handbook.\n\n[Sources]\n- marketing/lesson-plans/phase-05.5.md\n[/Sources]</a:t>
+              <a:t>Teach from docs/phases/05.5 and docs/ai-program.\n\n[Sources]\n- marketing/lesson-plans/phase-05.5.md\n[/Sources]</a:t>
             </a:r>
           </a:p>
         </p:txBody>
@@ -1246,7 +1246,7 @@
           <a:lstStyle xmlns:a="http://schemas.openxmlformats.org/drawingml/2006/main"/>
           <a:p xmlns:a="http://schemas.openxmlformats.org/drawingml/2006/main">
             <a:r>
-              <a:t>Teach from docs/phases/05.5 and the skills-program handbook.\n\n[Sources]\n- marketing/lesson-plans/phase-05.5.md\n[/Sources]</a:t>
+              <a:t>Teach from docs/phases/05.5 and docs/ai-program.\n\n[Sources]\n- marketing/lesson-plans/phase-05.5.md\n[/Sources]</a:t>
             </a:r>
           </a:p>
         </p:txBody>
@@ -4202,17 +4202,17 @@
   </p:cSld>
   <p:clrMap bg1="lt1" tx1="dk1" bg2="lt2" tx2="dk2" accent1="accent1" accent2="accent2" accent3="accent3" accent4="accent4" accent5="accent5" accent6="accent6" hlink="hlink" folHlink="folHlink"/>
   <p:sldLayoutIdLst>
-    <p:sldLayoutId xmlns:r="http://schemas.openxmlformats.org/officeDocument/2006/relationships" id="2147483649" r:id="Rea3665e7624b4f22"/>
-    <p:sldLayoutId xmlns:r="http://schemas.openxmlformats.org/officeDocument/2006/relationships" id="2147483650" r:id="R2bf536d0cb7e451a"/>
-    <p:sldLayoutId xmlns:r="http://schemas.openxmlformats.org/officeDocument/2006/relationships" id="2147483651" r:id="R51f8c29a21c74d80"/>
-    <p:sldLayoutId xmlns:r="http://schemas.openxmlformats.org/officeDocument/2006/relationships" id="2147483652" r:id="Rbcd4e303b86848a8"/>
-    <p:sldLayoutId xmlns:r="http://schemas.openxmlformats.org/officeDocument/2006/relationships" id="2147483653" r:id="Rcf8d85a494604b00"/>
-    <p:sldLayoutId xmlns:r="http://schemas.openxmlformats.org/officeDocument/2006/relationships" id="2147483654" r:id="Rc0faf87cfd2c445b"/>
-    <p:sldLayoutId xmlns:r="http://schemas.openxmlformats.org/officeDocument/2006/relationships" id="2147483655" r:id="Rbb8c0db0c7fc4202"/>
-    <p:sldLayoutId xmlns:r="http://schemas.openxmlformats.org/officeDocument/2006/relationships" id="2147483656" r:id="R5a60c5e1b3fb4e17"/>
-    <p:sldLayoutId xmlns:r="http://schemas.openxmlformats.org/officeDocument/2006/relationships" id="2147483657" r:id="Rfd690d1bfba44338"/>
-    <p:sldLayoutId xmlns:r="http://schemas.openxmlformats.org/officeDocument/2006/relationships" id="2147483658" r:id="Rba1a46c4de054d8e"/>
-    <p:sldLayoutId xmlns:r="http://schemas.openxmlformats.org/officeDocument/2006/relationships" id="2147483659" r:id="R5bd20776ac364736"/>
+    <p:sldLayoutId xmlns:r="http://schemas.openxmlformats.org/officeDocument/2006/relationships" id="2147483649" r:id="Ra8d44a7b46754774"/>
+    <p:sldLayoutId xmlns:r="http://schemas.openxmlformats.org/officeDocument/2006/relationships" id="2147483650" r:id="R76ca7ce0fb4c4947"/>
+    <p:sldLayoutId xmlns:r="http://schemas.openxmlformats.org/officeDocument/2006/relationships" id="2147483651" r:id="Rabf21db7b9c44068"/>
+    <p:sldLayoutId xmlns:r="http://schemas.openxmlformats.org/officeDocument/2006/relationships" id="2147483652" r:id="R5b2fe6a4ba6640ea"/>
+    <p:sldLayoutId xmlns:r="http://schemas.openxmlformats.org/officeDocument/2006/relationships" id="2147483653" r:id="Rde27714d443c46f4"/>
+    <p:sldLayoutId xmlns:r="http://schemas.openxmlformats.org/officeDocument/2006/relationships" id="2147483654" r:id="Rfe9b867b527f473f"/>
+    <p:sldLayoutId xmlns:r="http://schemas.openxmlformats.org/officeDocument/2006/relationships" id="2147483655" r:id="Rbe6f0718ed194513"/>
+    <p:sldLayoutId xmlns:r="http://schemas.openxmlformats.org/officeDocument/2006/relationships" id="2147483656" r:id="R67a2cd5895b540c5"/>
+    <p:sldLayoutId xmlns:r="http://schemas.openxmlformats.org/officeDocument/2006/relationships" id="2147483657" r:id="R94cec887973d48de"/>
+    <p:sldLayoutId xmlns:r="http://schemas.openxmlformats.org/officeDocument/2006/relationships" id="2147483658" r:id="R12c8086c56a04acc"/>
+    <p:sldLayoutId xmlns:r="http://schemas.openxmlformats.org/officeDocument/2006/relationships" id="2147483659" r:id="R206527c3e8da4852"/>
   </p:sldLayoutIdLst>
   <p:txStyles>
     <p:titleStyle>
@@ -4889,7 +4889,7 @@
                 <a:ea typeface="Calibri"/>
                 <a:cs typeface="Calibri"/>
               </a:rPr>
-              <a:t>Phase 05.5 second coding effort</a:t>
+              <a:t>Phase 05.5 capability registry</a:t>
             </a:r>
           </a:p>
         </p:txBody>
@@ -4979,7 +4979,7 @@
                 <a:ea typeface="Calibri"/>
                 <a:cs typeface="Calibri"/>
               </a:rPr>
-              <a:t>The browser found skills. The registry governs their organizational life.</a:t>
+              <a:t>The locator found capabilities. The registry governs their organizational life.</a:t>
             </a:r>
           </a:p>
         </p:txBody>
@@ -5377,7 +5377,7 @@
                 <a:ea typeface="Calibri"/>
                 <a:cs typeface="Calibri"/>
               </a:rPr>
-              <a:t>approve + publish PR</a:t>
+              <a:t>approve + canonical PR</a:t>
             </a:r>
           </a:p>
         </p:txBody>
@@ -7147,7 +7147,7 @@
                 <a:ea typeface="Calibri Light"/>
                 <a:cs typeface="Calibri Light"/>
               </a:rPr>
-              <a:t>The second build changes the product contract</a:t>
+              <a:t>The existing build changes the product contract</a:t>
             </a:r>
           </a:p>
         </p:txBody>
@@ -7821,7 +7821,7 @@
                 <a:ea typeface="Calibri"/>
                 <a:cs typeface="Calibri"/>
               </a:rPr>
-              <a:t>policy + installations</a:t>
+              <a:t>policy + projections</a:t>
             </a:r>
           </a:p>
         </p:txBody>
@@ -9582,7 +9582,7 @@
                 <a:ea typeface="Calibri"/>
                 <a:cs typeface="Calibri"/>
               </a:rPr>
-              <a:t>project skill files</a:t>
+              <a:t>canonical ai/ source</a:t>
             </a:r>
           </a:p>
         </p:txBody>
@@ -10035,7 +10035,7 @@
                 <a:ea typeface="Calibri"/>
                 <a:cs typeface="Calibri"/>
               </a:rPr>
-              <a:t>skill + revision</a:t>
+              <a:t>capability + revision</a:t>
             </a:r>
           </a:p>
         </p:txBody>
@@ -10223,7 +10223,7 @@
                 <a:ea typeface="Calibri"/>
                 <a:cs typeface="Calibri"/>
               </a:rPr>
-              <a:t>installation</a:t>
+              <a:t>publication + use</a:t>
             </a:r>
           </a:p>
         </p:txBody>
@@ -11248,7 +11248,7 @@
                 <a:ea typeface="Calibri"/>
                 <a:cs typeface="Calibri"/>
               </a:rPr>
-              <a:t>installed hash</a:t>
+              <a:t>canonical hash</a:t>
             </a:r>
           </a:p>
         </p:txBody>
@@ -12899,7 +12899,7 @@
                 <a:ea typeface="Calibri"/>
                 <a:cs typeface="Calibri"/>
               </a:rPr>
-              <a:t>destination diff</a:t>
+              <a:t>native projections</a:t>
             </a:r>
           </a:p>
         </p:txBody>
@@ -13511,7 +13511,7 @@
                 <a:ea typeface="Calibri"/>
                 <a:cs typeface="Calibri"/>
               </a:rPr>
-              <a:t>installation + commit</a:t>
+              <a:t>publication + use</a:t>
             </a:r>
           </a:p>
         </p:txBody>
@@ -13768,7 +13768,7 @@
                 <a:ea typeface="Calibri"/>
                 <a:cs typeface="Calibri"/>
               </a:rPr>
-              <a:t>A skill name can stay stable while its behavior changes.</a:t>
+              <a:t>A capability name can stay stable while its behavior changes.</a:t>
             </a:r>
           </a:p>
         </p:txBody>

</xml_diff>